<commit_message>
Finalize D1-D7 project baseline
</commit_message>
<xml_diff>
--- a/reports/Bluestock_MF_Presentation.pptx
+++ b/reports/Bluestock_MF_Presentation.pptx
@@ -128,679 +128,10 @@
 <file path=ppt/revisionInfo.xml><?xml version="1.0" encoding="utf-8"?>
 <p1510:revInfo xmlns:a="http://schemas.openxmlformats.org/drawingml/2006/main" xmlns:r="http://schemas.openxmlformats.org/officeDocument/2006/relationships" xmlns:p1510="http://schemas.microsoft.com/office/powerpoint/2015/10/main">
   <p1510:revLst>
+    <p1510:client id="{00000000-0000-0000-0000-000000000000}" v="34" dt="2026-08-13T10:34:33.022"/>
     <p1510:client id="{62762BB7-53F3-41F3-8E74-F30F7B94F81C}" v="1124" dt="2026-08-11T11:45:08.493"/>
   </p1510:revLst>
 </p1510:revInfo>
-</file>
-
-<file path=ppt/changesInfos/changesInfo1.xml><?xml version="1.0" encoding="utf-8"?>
-<pc:chgInfo xmlns:a="http://schemas.openxmlformats.org/drawingml/2006/main" xmlns:r="http://schemas.openxmlformats.org/officeDocument/2006/relationships" xmlns:ac="http://schemas.microsoft.com/office/drawing/2013/main/command" xmlns:pc="http://schemas.microsoft.com/office/powerpoint/2013/main/command">
-  <pc:docChgLst>
-    <pc:chgData name="Balasa chenchu sai vyshnavi" userId="a0f446a0cc6dfce9" providerId="Windows Live" clId="Web-{62762BB7-53F3-41F3-8E74-F30F7B94F81C}"/>
-    <pc:docChg chg="addSld delSld modSld">
-      <pc:chgData name="Balasa chenchu sai vyshnavi" userId="a0f446a0cc6dfce9" providerId="Windows Live" clId="Web-{62762BB7-53F3-41F3-8E74-F30F7B94F81C}" dt="2026-08-11T11:45:08.493" v="892"/>
-      <pc:docMkLst>
-        <pc:docMk/>
-      </pc:docMkLst>
-      <pc:sldChg chg="addSp modSp">
-        <pc:chgData name="Balasa chenchu sai vyshnavi" userId="a0f446a0cc6dfce9" providerId="Windows Live" clId="Web-{62762BB7-53F3-41F3-8E74-F30F7B94F81C}" dt="2026-08-11T10:42:05.224" v="45" actId="20577"/>
-        <pc:sldMkLst>
-          <pc:docMk/>
-          <pc:sldMk cId="109857222" sldId="256"/>
-        </pc:sldMkLst>
-        <pc:spChg chg="mod">
-          <ac:chgData name="Balasa chenchu sai vyshnavi" userId="a0f446a0cc6dfce9" providerId="Windows Live" clId="Web-{62762BB7-53F3-41F3-8E74-F30F7B94F81C}" dt="2026-08-11T10:41:58.005" v="44" actId="20577"/>
-          <ac:spMkLst>
-            <pc:docMk/>
-            <pc:sldMk cId="109857222" sldId="256"/>
-            <ac:spMk id="2" creationId="{00000000-0000-0000-0000-000000000000}"/>
-          </ac:spMkLst>
-        </pc:spChg>
-        <pc:spChg chg="mod">
-          <ac:chgData name="Balasa chenchu sai vyshnavi" userId="a0f446a0cc6dfce9" providerId="Windows Live" clId="Web-{62762BB7-53F3-41F3-8E74-F30F7B94F81C}" dt="2026-08-11T10:42:05.224" v="45" actId="20577"/>
-          <ac:spMkLst>
-            <pc:docMk/>
-            <pc:sldMk cId="109857222" sldId="256"/>
-            <ac:spMk id="3" creationId="{00000000-0000-0000-0000-000000000000}"/>
-          </ac:spMkLst>
-        </pc:spChg>
-        <pc:spChg chg="add mod">
-          <ac:chgData name="Balasa chenchu sai vyshnavi" userId="a0f446a0cc6dfce9" providerId="Windows Live" clId="Web-{62762BB7-53F3-41F3-8E74-F30F7B94F81C}" dt="2026-08-11T10:41:51.598" v="43" actId="20577"/>
-          <ac:spMkLst>
-            <pc:docMk/>
-            <pc:sldMk cId="109857222" sldId="256"/>
-            <ac:spMk id="4" creationId="{4B3BA6B3-4FF2-393E-59F6-1040C4FB50B5}"/>
-          </ac:spMkLst>
-        </pc:spChg>
-      </pc:sldChg>
-      <pc:sldChg chg="addSp delSp modSp new">
-        <pc:chgData name="Balasa chenchu sai vyshnavi" userId="a0f446a0cc6dfce9" providerId="Windows Live" clId="Web-{62762BB7-53F3-41F3-8E74-F30F7B94F81C}" dt="2026-08-11T11:43:02.067" v="887" actId="20577"/>
-        <pc:sldMkLst>
-          <pc:docMk/>
-          <pc:sldMk cId="3950626946" sldId="257"/>
-        </pc:sldMkLst>
-        <pc:spChg chg="add mod">
-          <ac:chgData name="Balasa chenchu sai vyshnavi" userId="a0f446a0cc6dfce9" providerId="Windows Live" clId="Web-{62762BB7-53F3-41F3-8E74-F30F7B94F81C}" dt="2026-08-11T11:43:02.067" v="887" actId="20577"/>
-          <ac:spMkLst>
-            <pc:docMk/>
-            <pc:sldMk cId="3950626946" sldId="257"/>
-            <ac:spMk id="2" creationId="{C28EEEA5-84D8-FF26-7CED-2DFF4A2A8429}"/>
-          </ac:spMkLst>
-        </pc:spChg>
-        <pc:spChg chg="add del mod">
-          <ac:chgData name="Balasa chenchu sai vyshnavi" userId="a0f446a0cc6dfce9" providerId="Windows Live" clId="Web-{62762BB7-53F3-41F3-8E74-F30F7B94F81C}" dt="2026-08-11T10:43:48.836" v="91"/>
-          <ac:spMkLst>
-            <pc:docMk/>
-            <pc:sldMk cId="3950626946" sldId="257"/>
-            <ac:spMk id="3" creationId="{34A1F4AB-C293-95BA-415C-D694E845F3C6}"/>
-          </ac:spMkLst>
-        </pc:spChg>
-      </pc:sldChg>
-      <pc:sldChg chg="addSp modSp add replId">
-        <pc:chgData name="Balasa chenchu sai vyshnavi" userId="a0f446a0cc6dfce9" providerId="Windows Live" clId="Web-{62762BB7-53F3-41F3-8E74-F30F7B94F81C}" dt="2026-08-11T10:45:41.887" v="129" actId="20577"/>
-        <pc:sldMkLst>
-          <pc:docMk/>
-          <pc:sldMk cId="3389939794" sldId="258"/>
-        </pc:sldMkLst>
-        <pc:spChg chg="add mod">
-          <ac:chgData name="Balasa chenchu sai vyshnavi" userId="a0f446a0cc6dfce9" providerId="Windows Live" clId="Web-{62762BB7-53F3-41F3-8E74-F30F7B94F81C}" dt="2026-08-11T10:45:41.887" v="129" actId="20577"/>
-          <ac:spMkLst>
-            <pc:docMk/>
-            <pc:sldMk cId="3389939794" sldId="258"/>
-            <ac:spMk id="2" creationId="{34A1F4AB-C293-95BA-415C-D694E845F3C6}"/>
-          </ac:spMkLst>
-        </pc:spChg>
-      </pc:sldChg>
-      <pc:sldChg chg="addSp modSp add replId">
-        <pc:chgData name="Balasa chenchu sai vyshnavi" userId="a0f446a0cc6dfce9" providerId="Windows Live" clId="Web-{62762BB7-53F3-41F3-8E74-F30F7B94F81C}" dt="2026-08-11T10:55:24.001" v="340" actId="1076"/>
-        <pc:sldMkLst>
-          <pc:docMk/>
-          <pc:sldMk cId="1045682492" sldId="259"/>
-        </pc:sldMkLst>
-        <pc:spChg chg="add mod">
-          <ac:chgData name="Balasa chenchu sai vyshnavi" userId="a0f446a0cc6dfce9" providerId="Windows Live" clId="Web-{62762BB7-53F3-41F3-8E74-F30F7B94F81C}" dt="2026-08-11T10:46:50.905" v="142" actId="1076"/>
-          <ac:spMkLst>
-            <pc:docMk/>
-            <pc:sldMk cId="1045682492" sldId="259"/>
-            <ac:spMk id="2" creationId="{95BC82A9-6E37-8237-90C2-73163B1AA43F}"/>
-          </ac:spMkLst>
-        </pc:spChg>
-        <pc:spChg chg="add mod">
-          <ac:chgData name="Balasa chenchu sai vyshnavi" userId="a0f446a0cc6dfce9" providerId="Windows Live" clId="Web-{62762BB7-53F3-41F3-8E74-F30F7B94F81C}" dt="2026-08-11T10:55:24.001" v="340" actId="1076"/>
-          <ac:spMkLst>
-            <pc:docMk/>
-            <pc:sldMk cId="1045682492" sldId="259"/>
-            <ac:spMk id="4" creationId="{F86299F9-60EE-6B0A-AC37-FFCC3F497C44}"/>
-          </ac:spMkLst>
-        </pc:spChg>
-        <pc:graphicFrameChg chg="add mod modGraphic">
-          <ac:chgData name="Balasa chenchu sai vyshnavi" userId="a0f446a0cc6dfce9" providerId="Windows Live" clId="Web-{62762BB7-53F3-41F3-8E74-F30F7B94F81C}" dt="2026-08-11T10:54:13.108" v="335"/>
-          <ac:graphicFrameMkLst>
-            <pc:docMk/>
-            <pc:sldMk cId="1045682492" sldId="259"/>
-            <ac:graphicFrameMk id="3" creationId="{7552EA93-55DE-6BA5-8214-85ED29BBB410}"/>
-          </ac:graphicFrameMkLst>
-        </pc:graphicFrameChg>
-      </pc:sldChg>
-      <pc:sldChg chg="addSp delSp modSp add replId">
-        <pc:chgData name="Balasa chenchu sai vyshnavi" userId="a0f446a0cc6dfce9" providerId="Windows Live" clId="Web-{62762BB7-53F3-41F3-8E74-F30F7B94F81C}" dt="2026-08-11T11:43:16.208" v="890" actId="20577"/>
-        <pc:sldMkLst>
-          <pc:docMk/>
-          <pc:sldMk cId="58661674" sldId="260"/>
-        </pc:sldMkLst>
-        <pc:spChg chg="add mod">
-          <ac:chgData name="Balasa chenchu sai vyshnavi" userId="a0f446a0cc6dfce9" providerId="Windows Live" clId="Web-{62762BB7-53F3-41F3-8E74-F30F7B94F81C}" dt="2026-08-11T11:06:00.569" v="447"/>
-          <ac:spMkLst>
-            <pc:docMk/>
-            <pc:sldMk cId="58661674" sldId="260"/>
-            <ac:spMk id="2" creationId="{0D899D53-4C69-F9A2-68F8-F2CB90FDC992}"/>
-          </ac:spMkLst>
-        </pc:spChg>
-        <pc:spChg chg="add mod">
-          <ac:chgData name="Balasa chenchu sai vyshnavi" userId="a0f446a0cc6dfce9" providerId="Windows Live" clId="Web-{62762BB7-53F3-41F3-8E74-F30F7B94F81C}" dt="2026-08-11T11:43:16.208" v="890" actId="20577"/>
-          <ac:spMkLst>
-            <pc:docMk/>
-            <pc:sldMk cId="58661674" sldId="260"/>
-            <ac:spMk id="3" creationId="{FD8A23CB-4F19-45A7-3784-DD10991777E9}"/>
-          </ac:spMkLst>
-        </pc:spChg>
-        <pc:spChg chg="add mod">
-          <ac:chgData name="Balasa chenchu sai vyshnavi" userId="a0f446a0cc6dfce9" providerId="Windows Live" clId="Web-{62762BB7-53F3-41F3-8E74-F30F7B94F81C}" dt="2026-08-11T11:06:03.179" v="448"/>
-          <ac:spMkLst>
-            <pc:docMk/>
-            <pc:sldMk cId="58661674" sldId="260"/>
-            <ac:spMk id="4" creationId="{B33DFACF-E225-6909-7890-57E496EAFFF4}"/>
-          </ac:spMkLst>
-        </pc:spChg>
-        <pc:spChg chg="add mod">
-          <ac:chgData name="Balasa chenchu sai vyshnavi" userId="a0f446a0cc6dfce9" providerId="Windows Live" clId="Web-{62762BB7-53F3-41F3-8E74-F30F7B94F81C}" dt="2026-08-11T11:06:24.086" v="450"/>
-          <ac:spMkLst>
-            <pc:docMk/>
-            <pc:sldMk cId="58661674" sldId="260"/>
-            <ac:spMk id="5" creationId="{6D203DE9-47D3-7749-4DA3-F57B339718BC}"/>
-          </ac:spMkLst>
-        </pc:spChg>
-        <pc:spChg chg="add mod">
-          <ac:chgData name="Balasa chenchu sai vyshnavi" userId="a0f446a0cc6dfce9" providerId="Windows Live" clId="Web-{62762BB7-53F3-41F3-8E74-F30F7B94F81C}" dt="2026-08-11T11:06:19.476" v="449"/>
-          <ac:spMkLst>
-            <pc:docMk/>
-            <pc:sldMk cId="58661674" sldId="260"/>
-            <ac:spMk id="6" creationId="{58EF5259-6475-ACEE-FB2E-8D29C1DDE6FA}"/>
-          </ac:spMkLst>
-        </pc:spChg>
-        <pc:spChg chg="add mod">
-          <ac:chgData name="Balasa chenchu sai vyshnavi" userId="a0f446a0cc6dfce9" providerId="Windows Live" clId="Web-{62762BB7-53F3-41F3-8E74-F30F7B94F81C}" dt="2026-08-11T11:06:30.398" v="451"/>
-          <ac:spMkLst>
-            <pc:docMk/>
-            <pc:sldMk cId="58661674" sldId="260"/>
-            <ac:spMk id="7" creationId="{BAE8F1ED-FE7D-A1C3-E867-C1C058E02272}"/>
-          </ac:spMkLst>
-        </pc:spChg>
-        <pc:spChg chg="add mod">
-          <ac:chgData name="Balasa chenchu sai vyshnavi" userId="a0f446a0cc6dfce9" providerId="Windows Live" clId="Web-{62762BB7-53F3-41F3-8E74-F30F7B94F81C}" dt="2026-08-11T11:06:30.398" v="452"/>
-          <ac:spMkLst>
-            <pc:docMk/>
-            <pc:sldMk cId="58661674" sldId="260"/>
-            <ac:spMk id="8" creationId="{405DD307-343E-E342-361B-29B139CEB2D8}"/>
-          </ac:spMkLst>
-        </pc:spChg>
-        <pc:spChg chg="add mod">
-          <ac:chgData name="Balasa chenchu sai vyshnavi" userId="a0f446a0cc6dfce9" providerId="Windows Live" clId="Web-{62762BB7-53F3-41F3-8E74-F30F7B94F81C}" dt="2026-08-11T11:06:30.398" v="453"/>
-          <ac:spMkLst>
-            <pc:docMk/>
-            <pc:sldMk cId="58661674" sldId="260"/>
-            <ac:spMk id="9" creationId="{ECE36523-3BE2-39E8-DD1B-F4889BE931DE}"/>
-          </ac:spMkLst>
-        </pc:spChg>
-        <pc:spChg chg="add mod">
-          <ac:chgData name="Balasa chenchu sai vyshnavi" userId="a0f446a0cc6dfce9" providerId="Windows Live" clId="Web-{62762BB7-53F3-41F3-8E74-F30F7B94F81C}" dt="2026-08-11T11:06:30.445" v="454"/>
-          <ac:spMkLst>
-            <pc:docMk/>
-            <pc:sldMk cId="58661674" sldId="260"/>
-            <ac:spMk id="10" creationId="{76928794-FDF6-D4B7-C77C-BD19BFC717F1}"/>
-          </ac:spMkLst>
-        </pc:spChg>
-        <pc:spChg chg="add mod">
-          <ac:chgData name="Balasa chenchu sai vyshnavi" userId="a0f446a0cc6dfce9" providerId="Windows Live" clId="Web-{62762BB7-53F3-41F3-8E74-F30F7B94F81C}" dt="2026-08-11T11:07:13.884" v="466" actId="20577"/>
-          <ac:spMkLst>
-            <pc:docMk/>
-            <pc:sldMk cId="58661674" sldId="260"/>
-            <ac:spMk id="23" creationId="{24A2A45F-9DFB-5A34-6ED5-B0A5D49F7F90}"/>
-          </ac:spMkLst>
-        </pc:spChg>
-        <pc:cxnChg chg="add del mod">
-          <ac:chgData name="Balasa chenchu sai vyshnavi" userId="a0f446a0cc6dfce9" providerId="Windows Live" clId="Web-{62762BB7-53F3-41F3-8E74-F30F7B94F81C}" dt="2026-08-11T11:04:40.488" v="435"/>
-          <ac:cxnSpMkLst>
-            <pc:docMk/>
-            <pc:sldMk cId="58661674" sldId="260"/>
-            <ac:cxnSpMk id="11" creationId="{7FE355CE-552D-2B08-8290-AD308681FB37}"/>
-          </ac:cxnSpMkLst>
-        </pc:cxnChg>
-        <pc:cxnChg chg="add mod">
-          <ac:chgData name="Balasa chenchu sai vyshnavi" userId="a0f446a0cc6dfce9" providerId="Windows Live" clId="Web-{62762BB7-53F3-41F3-8E74-F30F7B94F81C}" dt="2026-08-11T11:01:28.201" v="399" actId="1076"/>
-          <ac:cxnSpMkLst>
-            <pc:docMk/>
-            <pc:sldMk cId="58661674" sldId="260"/>
-            <ac:cxnSpMk id="12" creationId="{99F15B98-B793-A591-84D6-487E42574929}"/>
-          </ac:cxnSpMkLst>
-        </pc:cxnChg>
-        <pc:cxnChg chg="add mod">
-          <ac:chgData name="Balasa chenchu sai vyshnavi" userId="a0f446a0cc6dfce9" providerId="Windows Live" clId="Web-{62762BB7-53F3-41F3-8E74-F30F7B94F81C}" dt="2026-08-11T11:01:50.639" v="404" actId="1076"/>
-          <ac:cxnSpMkLst>
-            <pc:docMk/>
-            <pc:sldMk cId="58661674" sldId="260"/>
-            <ac:cxnSpMk id="13" creationId="{B772D9AE-24D8-F4D5-7DE5-740EA58F9CF1}"/>
-          </ac:cxnSpMkLst>
-        </pc:cxnChg>
-        <pc:cxnChg chg="add mod">
-          <ac:chgData name="Balasa chenchu sai vyshnavi" userId="a0f446a0cc6dfce9" providerId="Windows Live" clId="Web-{62762BB7-53F3-41F3-8E74-F30F7B94F81C}" dt="2026-08-11T11:02:10.593" v="409" actId="14100"/>
-          <ac:cxnSpMkLst>
-            <pc:docMk/>
-            <pc:sldMk cId="58661674" sldId="260"/>
-            <ac:cxnSpMk id="14" creationId="{6F362098-61C1-9E5A-D216-C8C023DB859F}"/>
-          </ac:cxnSpMkLst>
-        </pc:cxnChg>
-        <pc:cxnChg chg="add del mod">
-          <ac:chgData name="Balasa chenchu sai vyshnavi" userId="a0f446a0cc6dfce9" providerId="Windows Live" clId="Web-{62762BB7-53F3-41F3-8E74-F30F7B94F81C}" dt="2026-08-11T11:02:55.469" v="418"/>
-          <ac:cxnSpMkLst>
-            <pc:docMk/>
-            <pc:sldMk cId="58661674" sldId="260"/>
-            <ac:cxnSpMk id="15" creationId="{01A740BD-13A6-3E86-F652-7D6606CB0B02}"/>
-          </ac:cxnSpMkLst>
-        </pc:cxnChg>
-        <pc:cxnChg chg="add del mod">
-          <ac:chgData name="Balasa chenchu sai vyshnavi" userId="a0f446a0cc6dfce9" providerId="Windows Live" clId="Web-{62762BB7-53F3-41F3-8E74-F30F7B94F81C}" dt="2026-08-11T11:03:25.705" v="424"/>
-          <ac:cxnSpMkLst>
-            <pc:docMk/>
-            <pc:sldMk cId="58661674" sldId="260"/>
-            <ac:cxnSpMk id="16" creationId="{26C5DE5D-A501-FA19-D7E7-9CC2F0F8540B}"/>
-          </ac:cxnSpMkLst>
-        </pc:cxnChg>
-        <pc:cxnChg chg="add">
-          <ac:chgData name="Balasa chenchu sai vyshnavi" userId="a0f446a0cc6dfce9" providerId="Windows Live" clId="Web-{62762BB7-53F3-41F3-8E74-F30F7B94F81C}" dt="2026-08-11T11:03:36.158" v="425"/>
-          <ac:cxnSpMkLst>
-            <pc:docMk/>
-            <pc:sldMk cId="58661674" sldId="260"/>
-            <ac:cxnSpMk id="17" creationId="{36BFC9CD-88FA-0880-3AE0-FB024C5C4B6D}"/>
-          </ac:cxnSpMkLst>
-        </pc:cxnChg>
-        <pc:cxnChg chg="add mod">
-          <ac:chgData name="Balasa chenchu sai vyshnavi" userId="a0f446a0cc6dfce9" providerId="Windows Live" clId="Web-{62762BB7-53F3-41F3-8E74-F30F7B94F81C}" dt="2026-08-11T11:03:55.315" v="430" actId="14100"/>
-          <ac:cxnSpMkLst>
-            <pc:docMk/>
-            <pc:sldMk cId="58661674" sldId="260"/>
-            <ac:cxnSpMk id="18" creationId="{247102EC-3062-ED4C-8970-8E7E902E33DF}"/>
-          </ac:cxnSpMkLst>
-        </pc:cxnChg>
-        <pc:cxnChg chg="add del mod">
-          <ac:chgData name="Balasa chenchu sai vyshnavi" userId="a0f446a0cc6dfce9" providerId="Windows Live" clId="Web-{62762BB7-53F3-41F3-8E74-F30F7B94F81C}" dt="2026-08-11T11:04:51.036" v="437"/>
-          <ac:cxnSpMkLst>
-            <pc:docMk/>
-            <pc:sldMk cId="58661674" sldId="260"/>
-            <ac:cxnSpMk id="19" creationId="{15152CC2-5565-700B-11EF-8347EFCE66D0}"/>
-          </ac:cxnSpMkLst>
-        </pc:cxnChg>
-        <pc:cxnChg chg="add mod">
-          <ac:chgData name="Balasa chenchu sai vyshnavi" userId="a0f446a0cc6dfce9" providerId="Windows Live" clId="Web-{62762BB7-53F3-41F3-8E74-F30F7B94F81C}" dt="2026-08-11T11:05:00.317" v="439" actId="1076"/>
-          <ac:cxnSpMkLst>
-            <pc:docMk/>
-            <pc:sldMk cId="58661674" sldId="260"/>
-            <ac:cxnSpMk id="20" creationId="{DE22E88F-9822-E8A9-D948-CEA49CB438AC}"/>
-          </ac:cxnSpMkLst>
-        </pc:cxnChg>
-        <pc:cxnChg chg="add del mod">
-          <ac:chgData name="Balasa chenchu sai vyshnavi" userId="a0f446a0cc6dfce9" providerId="Windows Live" clId="Web-{62762BB7-53F3-41F3-8E74-F30F7B94F81C}" dt="2026-08-11T11:05:21.849" v="443"/>
-          <ac:cxnSpMkLst>
-            <pc:docMk/>
-            <pc:sldMk cId="58661674" sldId="260"/>
-            <ac:cxnSpMk id="21" creationId="{025D4B97-9AD5-175D-F214-B7F57157BB05}"/>
-          </ac:cxnSpMkLst>
-        </pc:cxnChg>
-        <pc:cxnChg chg="add">
-          <ac:chgData name="Balasa chenchu sai vyshnavi" userId="a0f446a0cc6dfce9" providerId="Windows Live" clId="Web-{62762BB7-53F3-41F3-8E74-F30F7B94F81C}" dt="2026-08-11T11:05:31.553" v="444"/>
-          <ac:cxnSpMkLst>
-            <pc:docMk/>
-            <pc:sldMk cId="58661674" sldId="260"/>
-            <ac:cxnSpMk id="22" creationId="{B5EBAB26-FD4A-A0CC-AB0B-EC6A18348E10}"/>
-          </ac:cxnSpMkLst>
-        </pc:cxnChg>
-      </pc:sldChg>
-      <pc:sldChg chg="addSp delSp modSp add replId">
-        <pc:chgData name="Balasa chenchu sai vyshnavi" userId="a0f446a0cc6dfce9" providerId="Windows Live" clId="Web-{62762BB7-53F3-41F3-8E74-F30F7B94F81C}" dt="2026-08-11T11:12:22.317" v="502" actId="20577"/>
-        <pc:sldMkLst>
-          <pc:docMk/>
-          <pc:sldMk cId="4162261687" sldId="261"/>
-        </pc:sldMkLst>
-        <pc:spChg chg="add mod">
-          <ac:chgData name="Balasa chenchu sai vyshnavi" userId="a0f446a0cc6dfce9" providerId="Windows Live" clId="Web-{62762BB7-53F3-41F3-8E74-F30F7B94F81C}" dt="2026-08-11T11:07:49.417" v="478" actId="1076"/>
-          <ac:spMkLst>
-            <pc:docMk/>
-            <pc:sldMk cId="4162261687" sldId="261"/>
-            <ac:spMk id="2" creationId="{F93CC37B-2CB2-D7AA-9DD2-97BFBE2A149B}"/>
-          </ac:spMkLst>
-        </pc:spChg>
-        <pc:spChg chg="add mod">
-          <ac:chgData name="Balasa chenchu sai vyshnavi" userId="a0f446a0cc6dfce9" providerId="Windows Live" clId="Web-{62762BB7-53F3-41F3-8E74-F30F7B94F81C}" dt="2026-08-11T11:12:22.317" v="502" actId="20577"/>
-          <ac:spMkLst>
-            <pc:docMk/>
-            <pc:sldMk cId="4162261687" sldId="261"/>
-            <ac:spMk id="7" creationId="{F60B96A0-71B3-0C80-780F-282409F2E35D}"/>
-          </ac:spMkLst>
-        </pc:spChg>
-        <pc:picChg chg="add del mod">
-          <ac:chgData name="Balasa chenchu sai vyshnavi" userId="a0f446a0cc6dfce9" providerId="Windows Live" clId="Web-{62762BB7-53F3-41F3-8E74-F30F7B94F81C}" dt="2026-08-11T11:10:31.360" v="486"/>
-          <ac:picMkLst>
-            <pc:docMk/>
-            <pc:sldMk cId="4162261687" sldId="261"/>
-            <ac:picMk id="3" creationId="{53F39303-AAF6-15E6-F9E7-D6F29027CD5C}"/>
-          </ac:picMkLst>
-        </pc:picChg>
-        <pc:picChg chg="add del mod">
-          <ac:chgData name="Balasa chenchu sai vyshnavi" userId="a0f446a0cc6dfce9" providerId="Windows Live" clId="Web-{62762BB7-53F3-41F3-8E74-F30F7B94F81C}" dt="2026-08-11T11:10:31.360" v="485"/>
-          <ac:picMkLst>
-            <pc:docMk/>
-            <pc:sldMk cId="4162261687" sldId="261"/>
-            <ac:picMk id="4" creationId="{FDCB0486-431E-EA78-FF9E-1599ACBC17C1}"/>
-          </ac:picMkLst>
-        </pc:picChg>
-        <pc:picChg chg="add mod">
-          <ac:chgData name="Balasa chenchu sai vyshnavi" userId="a0f446a0cc6dfce9" providerId="Windows Live" clId="Web-{62762BB7-53F3-41F3-8E74-F30F7B94F81C}" dt="2026-08-11T11:11:19.393" v="495" actId="14100"/>
-          <ac:picMkLst>
-            <pc:docMk/>
-            <pc:sldMk cId="4162261687" sldId="261"/>
-            <ac:picMk id="5" creationId="{D738D67E-6DD2-054A-F396-143AB07468D0}"/>
-          </ac:picMkLst>
-        </pc:picChg>
-        <pc:picChg chg="add mod">
-          <ac:chgData name="Balasa chenchu sai vyshnavi" userId="a0f446a0cc6dfce9" providerId="Windows Live" clId="Web-{62762BB7-53F3-41F3-8E74-F30F7B94F81C}" dt="2026-08-11T11:11:14.283" v="494" actId="1076"/>
-          <ac:picMkLst>
-            <pc:docMk/>
-            <pc:sldMk cId="4162261687" sldId="261"/>
-            <ac:picMk id="6" creationId="{28015174-0AB2-5311-8BD3-CB1BBCFEA0C5}"/>
-          </ac:picMkLst>
-        </pc:picChg>
-      </pc:sldChg>
-      <pc:sldChg chg="addSp delSp modSp add replId">
-        <pc:chgData name="Balasa chenchu sai vyshnavi" userId="a0f446a0cc6dfce9" providerId="Windows Live" clId="Web-{62762BB7-53F3-41F3-8E74-F30F7B94F81C}" dt="2026-08-11T11:18:20.688" v="542" actId="1076"/>
-        <pc:sldMkLst>
-          <pc:docMk/>
-          <pc:sldMk cId="172537993" sldId="262"/>
-        </pc:sldMkLst>
-        <pc:spChg chg="add mod">
-          <ac:chgData name="Balasa chenchu sai vyshnavi" userId="a0f446a0cc6dfce9" providerId="Windows Live" clId="Web-{62762BB7-53F3-41F3-8E74-F30F7B94F81C}" dt="2026-08-11T11:16:21.044" v="512" actId="20577"/>
-          <ac:spMkLst>
-            <pc:docMk/>
-            <pc:sldMk cId="172537993" sldId="262"/>
-            <ac:spMk id="3" creationId="{A0AB0E1F-5F14-2BA9-5EF6-679EEC410AB2}"/>
-          </ac:spMkLst>
-        </pc:spChg>
-        <pc:spChg chg="add del mod">
-          <ac:chgData name="Balasa chenchu sai vyshnavi" userId="a0f446a0cc6dfce9" providerId="Windows Live" clId="Web-{62762BB7-53F3-41F3-8E74-F30F7B94F81C}" dt="2026-08-11T11:17:27.796" v="524"/>
-          <ac:spMkLst>
-            <pc:docMk/>
-            <pc:sldMk cId="172537993" sldId="262"/>
-            <ac:spMk id="6" creationId="{142FDEC8-A42E-9B94-F449-70049594FEA4}"/>
-          </ac:spMkLst>
-        </pc:spChg>
-        <pc:spChg chg="add del">
-          <ac:chgData name="Balasa chenchu sai vyshnavi" userId="a0f446a0cc6dfce9" providerId="Windows Live" clId="Web-{62762BB7-53F3-41F3-8E74-F30F7B94F81C}" dt="2026-08-11T11:17:38.749" v="526"/>
-          <ac:spMkLst>
-            <pc:docMk/>
-            <pc:sldMk cId="172537993" sldId="262"/>
-            <ac:spMk id="7" creationId="{3CA8C46B-5E6C-59E7-FAED-F4AC1CF8AE4E}"/>
-          </ac:spMkLst>
-        </pc:spChg>
-        <pc:spChg chg="add mod">
-          <ac:chgData name="Balasa chenchu sai vyshnavi" userId="a0f446a0cc6dfce9" providerId="Windows Live" clId="Web-{62762BB7-53F3-41F3-8E74-F30F7B94F81C}" dt="2026-08-11T11:18:20.688" v="542" actId="1076"/>
-          <ac:spMkLst>
-            <pc:docMk/>
-            <pc:sldMk cId="172537993" sldId="262"/>
-            <ac:spMk id="8" creationId="{30656066-CBEE-B1D3-9437-E8D9E1178C27}"/>
-          </ac:spMkLst>
-        </pc:spChg>
-        <pc:picChg chg="add mod">
-          <ac:chgData name="Balasa chenchu sai vyshnavi" userId="a0f446a0cc6dfce9" providerId="Windows Live" clId="Web-{62762BB7-53F3-41F3-8E74-F30F7B94F81C}" dt="2026-08-11T11:16:48.795" v="516" actId="14100"/>
-          <ac:picMkLst>
-            <pc:docMk/>
-            <pc:sldMk cId="172537993" sldId="262"/>
-            <ac:picMk id="4" creationId="{9E36C319-AAED-FBE7-F0A3-4AE837B2530D}"/>
-          </ac:picMkLst>
-        </pc:picChg>
-        <pc:picChg chg="add mod">
-          <ac:chgData name="Balasa chenchu sai vyshnavi" userId="a0f446a0cc6dfce9" providerId="Windows Live" clId="Web-{62762BB7-53F3-41F3-8E74-F30F7B94F81C}" dt="2026-08-11T11:17:08.326" v="520" actId="14100"/>
-          <ac:picMkLst>
-            <pc:docMk/>
-            <pc:sldMk cId="172537993" sldId="262"/>
-            <ac:picMk id="5" creationId="{8B43C327-7261-D1A5-B2F4-1DBBCB91133A}"/>
-          </ac:picMkLst>
-        </pc:picChg>
-      </pc:sldChg>
-      <pc:sldChg chg="addSp delSp modSp add replId">
-        <pc:chgData name="Balasa chenchu sai vyshnavi" userId="a0f446a0cc6dfce9" providerId="Windows Live" clId="Web-{62762BB7-53F3-41F3-8E74-F30F7B94F81C}" dt="2026-08-11T11:21:20.444" v="588" actId="20577"/>
-        <pc:sldMkLst>
-          <pc:docMk/>
-          <pc:sldMk cId="2014255672" sldId="263"/>
-        </pc:sldMkLst>
-        <pc:spChg chg="add del">
-          <ac:chgData name="Balasa chenchu sai vyshnavi" userId="a0f446a0cc6dfce9" providerId="Windows Live" clId="Web-{62762BB7-53F3-41F3-8E74-F30F7B94F81C}" dt="2026-08-11T11:18:46.299" v="544"/>
-          <ac:spMkLst>
-            <pc:docMk/>
-            <pc:sldMk cId="2014255672" sldId="263"/>
-            <ac:spMk id="2" creationId="{382C644B-0C07-098D-29D5-C52A12F83642}"/>
-          </ac:spMkLst>
-        </pc:spChg>
-        <pc:spChg chg="add mod">
-          <ac:chgData name="Balasa chenchu sai vyshnavi" userId="a0f446a0cc6dfce9" providerId="Windows Live" clId="Web-{62762BB7-53F3-41F3-8E74-F30F7B94F81C}" dt="2026-08-11T11:19:20.894" v="559" actId="1076"/>
-          <ac:spMkLst>
-            <pc:docMk/>
-            <pc:sldMk cId="2014255672" sldId="263"/>
-            <ac:spMk id="3" creationId="{13F3C5B7-B5F4-23E3-2C76-7BE5AA3265EC}"/>
-          </ac:spMkLst>
-        </pc:spChg>
-        <pc:spChg chg="add del">
-          <ac:chgData name="Balasa chenchu sai vyshnavi" userId="a0f446a0cc6dfce9" providerId="Windows Live" clId="Web-{62762BB7-53F3-41F3-8E74-F30F7B94F81C}" dt="2026-08-11T11:20:49.631" v="576"/>
-          <ac:spMkLst>
-            <pc:docMk/>
-            <pc:sldMk cId="2014255672" sldId="263"/>
-            <ac:spMk id="6" creationId="{1E6BBE6C-2282-A580-DEAF-2303DD08366F}"/>
-          </ac:spMkLst>
-        </pc:spChg>
-        <pc:spChg chg="add mod">
-          <ac:chgData name="Balasa chenchu sai vyshnavi" userId="a0f446a0cc6dfce9" providerId="Windows Live" clId="Web-{62762BB7-53F3-41F3-8E74-F30F7B94F81C}" dt="2026-08-11T11:21:20.444" v="588" actId="20577"/>
-          <ac:spMkLst>
-            <pc:docMk/>
-            <pc:sldMk cId="2014255672" sldId="263"/>
-            <ac:spMk id="7" creationId="{4197D1FC-304F-3FB0-CCF6-31D10C07D0A9}"/>
-          </ac:spMkLst>
-        </pc:spChg>
-        <pc:picChg chg="add mod">
-          <ac:chgData name="Balasa chenchu sai vyshnavi" userId="a0f446a0cc6dfce9" providerId="Windows Live" clId="Web-{62762BB7-53F3-41F3-8E74-F30F7B94F81C}" dt="2026-08-11T11:20:08.255" v="568" actId="14100"/>
-          <ac:picMkLst>
-            <pc:docMk/>
-            <pc:sldMk cId="2014255672" sldId="263"/>
-            <ac:picMk id="4" creationId="{6BB3534A-37F9-E74D-E619-78A6A42C92A9}"/>
-          </ac:picMkLst>
-        </pc:picChg>
-        <pc:picChg chg="add mod">
-          <ac:chgData name="Balasa chenchu sai vyshnavi" userId="a0f446a0cc6dfce9" providerId="Windows Live" clId="Web-{62762BB7-53F3-41F3-8E74-F30F7B94F81C}" dt="2026-08-11T11:20:33.365" v="574" actId="14100"/>
-          <ac:picMkLst>
-            <pc:docMk/>
-            <pc:sldMk cId="2014255672" sldId="263"/>
-            <ac:picMk id="5" creationId="{BB99D7FC-660A-5E37-B582-7E50614DBD5B}"/>
-          </ac:picMkLst>
-        </pc:picChg>
-      </pc:sldChg>
-      <pc:sldChg chg="addSp modSp add replId">
-        <pc:chgData name="Balasa chenchu sai vyshnavi" userId="a0f446a0cc6dfce9" providerId="Windows Live" clId="Web-{62762BB7-53F3-41F3-8E74-F30F7B94F81C}" dt="2026-08-11T11:24:07.450" v="637" actId="14100"/>
-        <pc:sldMkLst>
-          <pc:docMk/>
-          <pc:sldMk cId="3196304660" sldId="264"/>
-        </pc:sldMkLst>
-        <pc:spChg chg="add mod">
-          <ac:chgData name="Balasa chenchu sai vyshnavi" userId="a0f446a0cc6dfce9" providerId="Windows Live" clId="Web-{62762BB7-53F3-41F3-8E74-F30F7B94F81C}" dt="2026-08-11T11:22:00.540" v="605" actId="1076"/>
-          <ac:spMkLst>
-            <pc:docMk/>
-            <pc:sldMk cId="3196304660" sldId="264"/>
-            <ac:spMk id="2" creationId="{2BC08E96-8644-1675-BF17-D4BE73BF9BFB}"/>
-          </ac:spMkLst>
-        </pc:spChg>
-        <pc:spChg chg="add mod">
-          <ac:chgData name="Balasa chenchu sai vyshnavi" userId="a0f446a0cc6dfce9" providerId="Windows Live" clId="Web-{62762BB7-53F3-41F3-8E74-F30F7B94F81C}" dt="2026-08-11T11:24:01.106" v="635" actId="1076"/>
-          <ac:spMkLst>
-            <pc:docMk/>
-            <pc:sldMk cId="3196304660" sldId="264"/>
-            <ac:spMk id="5" creationId="{62AB9521-BFC2-0EEE-5173-96475407D654}"/>
-          </ac:spMkLst>
-        </pc:spChg>
-        <pc:picChg chg="add mod">
-          <ac:chgData name="Balasa chenchu sai vyshnavi" userId="a0f446a0cc6dfce9" providerId="Windows Live" clId="Web-{62762BB7-53F3-41F3-8E74-F30F7B94F81C}" dt="2026-08-11T11:24:03.934" v="636" actId="14100"/>
-          <ac:picMkLst>
-            <pc:docMk/>
-            <pc:sldMk cId="3196304660" sldId="264"/>
-            <ac:picMk id="3" creationId="{DBFB736F-0B51-46B1-B86F-6F67F3FC84F4}"/>
-          </ac:picMkLst>
-        </pc:picChg>
-        <pc:picChg chg="add mod">
-          <ac:chgData name="Balasa chenchu sai vyshnavi" userId="a0f446a0cc6dfce9" providerId="Windows Live" clId="Web-{62762BB7-53F3-41F3-8E74-F30F7B94F81C}" dt="2026-08-11T11:24:07.450" v="637" actId="14100"/>
-          <ac:picMkLst>
-            <pc:docMk/>
-            <pc:sldMk cId="3196304660" sldId="264"/>
-            <ac:picMk id="4" creationId="{8A30A9D7-3C08-38DD-796D-FBAA0222BF35}"/>
-          </ac:picMkLst>
-        </pc:picChg>
-      </pc:sldChg>
-      <pc:sldChg chg="addSp delSp modSp add replId">
-        <pc:chgData name="Balasa chenchu sai vyshnavi" userId="a0f446a0cc6dfce9" providerId="Windows Live" clId="Web-{62762BB7-53F3-41F3-8E74-F30F7B94F81C}" dt="2026-08-11T11:26:26.392" v="685" actId="1076"/>
-        <pc:sldMkLst>
-          <pc:docMk/>
-          <pc:sldMk cId="2779100265" sldId="265"/>
-        </pc:sldMkLst>
-        <pc:spChg chg="add del">
-          <ac:chgData name="Balasa chenchu sai vyshnavi" userId="a0f446a0cc6dfce9" providerId="Windows Live" clId="Web-{62762BB7-53F3-41F3-8E74-F30F7B94F81C}" dt="2026-08-11T11:24:29.045" v="640"/>
-          <ac:spMkLst>
-            <pc:docMk/>
-            <pc:sldMk cId="2779100265" sldId="265"/>
-            <ac:spMk id="2" creationId="{A097F166-9552-2C4D-75B4-856F8F982529}"/>
-          </ac:spMkLst>
-        </pc:spChg>
-        <pc:spChg chg="add mod">
-          <ac:chgData name="Balasa chenchu sai vyshnavi" userId="a0f446a0cc6dfce9" providerId="Windows Live" clId="Web-{62762BB7-53F3-41F3-8E74-F30F7B94F81C}" dt="2026-08-11T11:25:07.968" v="661" actId="1076"/>
-          <ac:spMkLst>
-            <pc:docMk/>
-            <pc:sldMk cId="2779100265" sldId="265"/>
-            <ac:spMk id="3" creationId="{C7EE91CF-BCE7-CFE2-EDFF-AABE3457B889}"/>
-          </ac:spMkLst>
-        </pc:spChg>
-        <pc:spChg chg="add mod">
-          <ac:chgData name="Balasa chenchu sai vyshnavi" userId="a0f446a0cc6dfce9" providerId="Windows Live" clId="Web-{62762BB7-53F3-41F3-8E74-F30F7B94F81C}" dt="2026-08-11T11:26:26.392" v="685" actId="1076"/>
-          <ac:spMkLst>
-            <pc:docMk/>
-            <pc:sldMk cId="2779100265" sldId="265"/>
-            <ac:spMk id="6" creationId="{C18DBF10-60EC-6851-0098-1C658BE499E9}"/>
-          </ac:spMkLst>
-        </pc:spChg>
-        <pc:picChg chg="add mod">
-          <ac:chgData name="Balasa chenchu sai vyshnavi" userId="a0f446a0cc6dfce9" providerId="Windows Live" clId="Web-{62762BB7-53F3-41F3-8E74-F30F7B94F81C}" dt="2026-08-11T11:25:35.984" v="667" actId="1076"/>
-          <ac:picMkLst>
-            <pc:docMk/>
-            <pc:sldMk cId="2779100265" sldId="265"/>
-            <ac:picMk id="4" creationId="{FD811E5F-FAFE-850C-007A-F6A339DFF53D}"/>
-          </ac:picMkLst>
-        </pc:picChg>
-        <pc:picChg chg="add mod">
-          <ac:chgData name="Balasa chenchu sai vyshnavi" userId="a0f446a0cc6dfce9" providerId="Windows Live" clId="Web-{62762BB7-53F3-41F3-8E74-F30F7B94F81C}" dt="2026-08-11T11:26:00.454" v="675" actId="1076"/>
-          <ac:picMkLst>
-            <pc:docMk/>
-            <pc:sldMk cId="2779100265" sldId="265"/>
-            <ac:picMk id="5" creationId="{69276BAD-36D2-F8B2-C833-48ED51F8EA37}"/>
-          </ac:picMkLst>
-        </pc:picChg>
-      </pc:sldChg>
-      <pc:sldChg chg="addSp delSp modSp add replId">
-        <pc:chgData name="Balasa chenchu sai vyshnavi" userId="a0f446a0cc6dfce9" providerId="Windows Live" clId="Web-{62762BB7-53F3-41F3-8E74-F30F7B94F81C}" dt="2026-08-11T11:39:26.825" v="859" actId="1076"/>
-        <pc:sldMkLst>
-          <pc:docMk/>
-          <pc:sldMk cId="2787201765" sldId="266"/>
-        </pc:sldMkLst>
-        <pc:spChg chg="add del">
-          <ac:chgData name="Balasa chenchu sai vyshnavi" userId="a0f446a0cc6dfce9" providerId="Windows Live" clId="Web-{62762BB7-53F3-41F3-8E74-F30F7B94F81C}" dt="2026-08-11T11:26:54.143" v="687"/>
-          <ac:spMkLst>
-            <pc:docMk/>
-            <pc:sldMk cId="2787201765" sldId="266"/>
-            <ac:spMk id="2" creationId="{4F467000-8E67-BEB4-9D42-43DC9F69C68C}"/>
-          </ac:spMkLst>
-        </pc:spChg>
-        <pc:spChg chg="add mod">
-          <ac:chgData name="Balasa chenchu sai vyshnavi" userId="a0f446a0cc6dfce9" providerId="Windows Live" clId="Web-{62762BB7-53F3-41F3-8E74-F30F7B94F81C}" dt="2026-08-11T11:27:31.379" v="702" actId="1076"/>
-          <ac:spMkLst>
-            <pc:docMk/>
-            <pc:sldMk cId="2787201765" sldId="266"/>
-            <ac:spMk id="3" creationId="{56351907-6595-1B9F-D078-F6ED84E5D5D7}"/>
-          </ac:spMkLst>
-        </pc:spChg>
-        <pc:spChg chg="add mod">
-          <ac:chgData name="Balasa chenchu sai vyshnavi" userId="a0f446a0cc6dfce9" providerId="Windows Live" clId="Web-{62762BB7-53F3-41F3-8E74-F30F7B94F81C}" dt="2026-08-11T11:39:26.825" v="859" actId="1076"/>
-          <ac:spMkLst>
-            <pc:docMk/>
-            <pc:sldMk cId="2787201765" sldId="266"/>
-            <ac:spMk id="6" creationId="{F4AD309E-6FBE-605B-3728-F9639E54EDF4}"/>
-          </ac:spMkLst>
-        </pc:spChg>
-        <pc:picChg chg="add mod">
-          <ac:chgData name="Balasa chenchu sai vyshnavi" userId="a0f446a0cc6dfce9" providerId="Windows Live" clId="Web-{62762BB7-53F3-41F3-8E74-F30F7B94F81C}" dt="2026-08-11T11:39:07.700" v="854" actId="14100"/>
-          <ac:picMkLst>
-            <pc:docMk/>
-            <pc:sldMk cId="2787201765" sldId="266"/>
-            <ac:picMk id="4" creationId="{0E6BD8FE-E10A-A574-7A77-B66713450C45}"/>
-          </ac:picMkLst>
-        </pc:picChg>
-        <pc:picChg chg="add del mod">
-          <ac:chgData name="Balasa chenchu sai vyshnavi" userId="a0f446a0cc6dfce9" providerId="Windows Live" clId="Web-{62762BB7-53F3-41F3-8E74-F30F7B94F81C}" dt="2026-08-11T11:38:07.213" v="837"/>
-          <ac:picMkLst>
-            <pc:docMk/>
-            <pc:sldMk cId="2787201765" sldId="266"/>
-            <ac:picMk id="5" creationId="{13847477-FC71-3804-358D-F97F929E1417}"/>
-          </ac:picMkLst>
-        </pc:picChg>
-      </pc:sldChg>
-      <pc:sldChg chg="addSp modSp add replId">
-        <pc:chgData name="Balasa chenchu sai vyshnavi" userId="a0f446a0cc6dfce9" providerId="Windows Live" clId="Web-{62762BB7-53F3-41F3-8E74-F30F7B94F81C}" dt="2026-08-11T11:41:10.626" v="886" actId="20577"/>
-        <pc:sldMkLst>
-          <pc:docMk/>
-          <pc:sldMk cId="2212459728" sldId="267"/>
-        </pc:sldMkLst>
-        <pc:spChg chg="add mod">
-          <ac:chgData name="Balasa chenchu sai vyshnavi" userId="a0f446a0cc6dfce9" providerId="Windows Live" clId="Web-{62762BB7-53F3-41F3-8E74-F30F7B94F81C}" dt="2026-08-11T11:41:10.626" v="886" actId="20577"/>
-          <ac:spMkLst>
-            <pc:docMk/>
-            <pc:sldMk cId="2212459728" sldId="267"/>
-            <ac:spMk id="3" creationId="{00459A6D-6E11-D0D9-8114-3F7E5B910A04}"/>
-          </ac:spMkLst>
-        </pc:spChg>
-        <pc:picChg chg="add mod modCrop">
-          <ac:chgData name="Balasa chenchu sai vyshnavi" userId="a0f446a0cc6dfce9" providerId="Windows Live" clId="Web-{62762BB7-53F3-41F3-8E74-F30F7B94F81C}" dt="2026-08-11T11:40:39.593" v="876" actId="1076"/>
-          <ac:picMkLst>
-            <pc:docMk/>
-            <pc:sldMk cId="2212459728" sldId="267"/>
-            <ac:picMk id="2" creationId="{623DFFF0-62FC-44FF-A4DA-C11775B82522}"/>
-          </ac:picMkLst>
-        </pc:picChg>
-      </pc:sldChg>
-      <pc:sldChg chg="addSp modSp add replId">
-        <pc:chgData name="Balasa chenchu sai vyshnavi" userId="a0f446a0cc6dfce9" providerId="Windows Live" clId="Web-{62762BB7-53F3-41F3-8E74-F30F7B94F81C}" dt="2026-08-11T11:36:01.928" v="825" actId="20577"/>
-        <pc:sldMkLst>
-          <pc:docMk/>
-          <pc:sldMk cId="2759358244" sldId="268"/>
-        </pc:sldMkLst>
-        <pc:spChg chg="add mod">
-          <ac:chgData name="Balasa chenchu sai vyshnavi" userId="a0f446a0cc6dfce9" providerId="Windows Live" clId="Web-{62762BB7-53F3-41F3-8E74-F30F7B94F81C}" dt="2026-08-11T11:34:55.019" v="810" actId="1076"/>
-          <ac:spMkLst>
-            <pc:docMk/>
-            <pc:sldMk cId="2759358244" sldId="268"/>
-            <ac:spMk id="2" creationId="{27FC9663-E645-7519-9DA1-EB55C4AD9DA7}"/>
-          </ac:spMkLst>
-        </pc:spChg>
-        <pc:spChg chg="add mod">
-          <ac:chgData name="Balasa chenchu sai vyshnavi" userId="a0f446a0cc6dfce9" providerId="Windows Live" clId="Web-{62762BB7-53F3-41F3-8E74-F30F7B94F81C}" dt="2026-08-11T11:36:01.928" v="825" actId="20577"/>
-          <ac:spMkLst>
-            <pc:docMk/>
-            <pc:sldMk cId="2759358244" sldId="268"/>
-            <ac:spMk id="3" creationId="{2E3501A7-05A7-AD41-820D-A2F9675EC0E7}"/>
-          </ac:spMkLst>
-        </pc:spChg>
-      </pc:sldChg>
-      <pc:sldChg chg="addSp modSp add replId">
-        <pc:chgData name="Balasa chenchu sai vyshnavi" userId="a0f446a0cc6dfce9" providerId="Windows Live" clId="Web-{62762BB7-53F3-41F3-8E74-F30F7B94F81C}" dt="2026-08-11T11:33:32.157" v="797" actId="1076"/>
-        <pc:sldMkLst>
-          <pc:docMk/>
-          <pc:sldMk cId="2222953911" sldId="269"/>
-        </pc:sldMkLst>
-        <pc:spChg chg="add mod">
-          <ac:chgData name="Balasa chenchu sai vyshnavi" userId="a0f446a0cc6dfce9" providerId="Windows Live" clId="Web-{62762BB7-53F3-41F3-8E74-F30F7B94F81C}" dt="2026-08-11T11:33:32.157" v="797" actId="1076"/>
-          <ac:spMkLst>
-            <pc:docMk/>
-            <pc:sldMk cId="2222953911" sldId="269"/>
-            <ac:spMk id="2" creationId="{D4608C1A-6134-4A5F-D6A5-880FEB9D4EB1}"/>
-          </ac:spMkLst>
-        </pc:spChg>
-      </pc:sldChg>
-      <pc:sldChg chg="add del replId">
-        <pc:chgData name="Balasa chenchu sai vyshnavi" userId="a0f446a0cc6dfce9" providerId="Windows Live" clId="Web-{62762BB7-53F3-41F3-8E74-F30F7B94F81C}" dt="2026-08-11T11:45:07.165" v="891"/>
-        <pc:sldMkLst>
-          <pc:docMk/>
-          <pc:sldMk cId="2323439287" sldId="270"/>
-        </pc:sldMkLst>
-      </pc:sldChg>
-      <pc:sldChg chg="add del replId">
-        <pc:chgData name="Balasa chenchu sai vyshnavi" userId="a0f446a0cc6dfce9" providerId="Windows Live" clId="Web-{62762BB7-53F3-41F3-8E74-F30F7B94F81C}" dt="2026-08-11T11:45:08.493" v="892"/>
-        <pc:sldMkLst>
-          <pc:docMk/>
-          <pc:sldMk cId="3234811444" sldId="271"/>
-        </pc:sldMkLst>
-      </pc:sldChg>
-    </pc:docChg>
-  </pc:docChgLst>
-</pc:chgInfo>
 </file>
 
 <file path=ppt/slideLayouts/slideLayout1.xml><?xml version="1.0" encoding="utf-8"?>
@@ -934,7 +265,7 @@
           <a:p>
             <a:fld id="{846CE7D5-CF57-46EF-B807-FDD0502418D4}" type="datetimeFigureOut">
               <a:rPr lang="en-US" smtClean="0"/>
-              <a:t>8/11/2026</a:t>
+              <a:t>8/13/2026</a:t>
             </a:fld>
             <a:endParaRPr lang="en-US"/>
           </a:p>
@@ -1104,7 +435,7 @@
           <a:p>
             <a:fld id="{846CE7D5-CF57-46EF-B807-FDD0502418D4}" type="datetimeFigureOut">
               <a:rPr lang="en-US" smtClean="0"/>
-              <a:t>8/11/2026</a:t>
+              <a:t>8/13/2026</a:t>
             </a:fld>
             <a:endParaRPr lang="en-US"/>
           </a:p>
@@ -1284,7 +615,7 @@
           <a:p>
             <a:fld id="{846CE7D5-CF57-46EF-B807-FDD0502418D4}" type="datetimeFigureOut">
               <a:rPr lang="en-US" smtClean="0"/>
-              <a:t>8/11/2026</a:t>
+              <a:t>8/13/2026</a:t>
             </a:fld>
             <a:endParaRPr lang="en-US"/>
           </a:p>
@@ -1454,7 +785,7 @@
           <a:p>
             <a:fld id="{846CE7D5-CF57-46EF-B807-FDD0502418D4}" type="datetimeFigureOut">
               <a:rPr lang="en-US" smtClean="0"/>
-              <a:t>8/11/2026</a:t>
+              <a:t>8/13/2026</a:t>
             </a:fld>
             <a:endParaRPr lang="en-US"/>
           </a:p>
@@ -1700,7 +1031,7 @@
           <a:p>
             <a:fld id="{846CE7D5-CF57-46EF-B807-FDD0502418D4}" type="datetimeFigureOut">
               <a:rPr lang="en-US" smtClean="0"/>
-              <a:t>8/11/2026</a:t>
+              <a:t>8/13/2026</a:t>
             </a:fld>
             <a:endParaRPr lang="en-US"/>
           </a:p>
@@ -1932,7 +1263,7 @@
           <a:p>
             <a:fld id="{846CE7D5-CF57-46EF-B807-FDD0502418D4}" type="datetimeFigureOut">
               <a:rPr lang="en-US" smtClean="0"/>
-              <a:t>8/11/2026</a:t>
+              <a:t>8/13/2026</a:t>
             </a:fld>
             <a:endParaRPr lang="en-US"/>
           </a:p>
@@ -2299,7 +1630,7 @@
           <a:p>
             <a:fld id="{846CE7D5-CF57-46EF-B807-FDD0502418D4}" type="datetimeFigureOut">
               <a:rPr lang="en-US" smtClean="0"/>
-              <a:t>8/11/2026</a:t>
+              <a:t>8/13/2026</a:t>
             </a:fld>
             <a:endParaRPr lang="en-US"/>
           </a:p>
@@ -2417,7 +1748,7 @@
           <a:p>
             <a:fld id="{846CE7D5-CF57-46EF-B807-FDD0502418D4}" type="datetimeFigureOut">
               <a:rPr lang="en-US" smtClean="0"/>
-              <a:t>8/11/2026</a:t>
+              <a:t>8/13/2026</a:t>
             </a:fld>
             <a:endParaRPr lang="en-US"/>
           </a:p>
@@ -2512,7 +1843,7 @@
           <a:p>
             <a:fld id="{846CE7D5-CF57-46EF-B807-FDD0502418D4}" type="datetimeFigureOut">
               <a:rPr lang="en-US" smtClean="0"/>
-              <a:t>8/11/2026</a:t>
+              <a:t>8/13/2026</a:t>
             </a:fld>
             <a:endParaRPr lang="en-US"/>
           </a:p>
@@ -2789,7 +2120,7 @@
           <a:p>
             <a:fld id="{846CE7D5-CF57-46EF-B807-FDD0502418D4}" type="datetimeFigureOut">
               <a:rPr lang="en-US" smtClean="0"/>
-              <a:t>8/11/2026</a:t>
+              <a:t>8/13/2026</a:t>
             </a:fld>
             <a:endParaRPr lang="en-US"/>
           </a:p>
@@ -3042,7 +2373,7 @@
           <a:p>
             <a:fld id="{846CE7D5-CF57-46EF-B807-FDD0502418D4}" type="datetimeFigureOut">
               <a:rPr lang="en-US" smtClean="0"/>
-              <a:t>8/11/2026</a:t>
+              <a:t>8/13/2026</a:t>
             </a:fld>
             <a:endParaRPr lang="en-US"/>
           </a:p>
@@ -3255,7 +2586,7 @@
           <a:p>
             <a:fld id="{846CE7D5-CF57-46EF-B807-FDD0502418D4}" type="datetimeFigureOut">
               <a:rPr lang="en-US" smtClean="0"/>
-              <a:t>8/11/2026</a:t>
+              <a:t>8/13/2026</a:t>
             </a:fld>
             <a:endParaRPr lang="en-US"/>
           </a:p>
@@ -3683,14 +3014,14 @@
           <a:lstStyle/>
           <a:p>
             <a:r>
-              <a:rPr lang="en-US">
+              <a:rPr lang="en-US" b="1">
                 <a:latin typeface="Times New Roman"/>
                 <a:ea typeface="+mj-lt"/>
                 <a:cs typeface="Times New Roman"/>
               </a:rPr>
               <a:t>BLUESTOCK MUTUAL FUND ANALYTICS</a:t>
             </a:r>
-            <a:endParaRPr lang="en-US">
+            <a:endParaRPr lang="en-US" b="1">
               <a:latin typeface="Times New Roman"/>
               <a:cs typeface="Times New Roman"/>
             </a:endParaRPr>
@@ -3720,7 +3051,7 @@
           <a:lstStyle/>
           <a:p>
             <a:r>
-              <a:rPr lang="en-US" dirty="0">
+              <a:rPr lang="en-US" b="1" dirty="0">
                 <a:latin typeface="Times New Roman"/>
                 <a:ea typeface="+mn-lt"/>
                 <a:cs typeface="Times New Roman"/>
@@ -3728,14 +3059,14 @@
               <a:t>Data-Driven Analysis of Mutual Fund Performance, Risk and Investor </a:t>
             </a:r>
             <a:r>
-              <a:rPr lang="en-US" dirty="0" err="1">
+              <a:rPr lang="en-US" b="1" dirty="0" err="1">
                 <a:latin typeface="Times New Roman"/>
                 <a:ea typeface="+mn-lt"/>
                 <a:cs typeface="Times New Roman"/>
               </a:rPr>
               <a:t>Behaviour</a:t>
             </a:r>
-            <a:endParaRPr lang="en-US">
+            <a:endParaRPr lang="en-US" b="1" dirty="0">
               <a:latin typeface="Times New Roman"/>
               <a:ea typeface="+mn-lt"/>
               <a:cs typeface="Times New Roman"/>
@@ -3743,14 +3074,14 @@
           </a:p>
           <a:p>
             <a:r>
-              <a:rPr lang="en-US">
+              <a:rPr lang="en-US" b="1">
                 <a:latin typeface="Times New Roman"/>
                 <a:ea typeface="+mn-lt"/>
                 <a:cs typeface="Times New Roman"/>
               </a:rPr>
               <a:t>Final Capstone Project</a:t>
             </a:r>
-            <a:endParaRPr lang="en-US">
+            <a:endParaRPr lang="en-US" b="1">
               <a:latin typeface="Times New Roman"/>
               <a:cs typeface="Times New Roman"/>
             </a:endParaRPr>
@@ -5238,7 +4569,7 @@
         <p:spPr>
           <a:xfrm>
             <a:off x="807492" y="699448"/>
-            <a:ext cx="10349552" cy="5262979"/>
+            <a:ext cx="10349552" cy="4585871"/>
           </a:xfrm>
           <a:prstGeom prst="rect">
             <a:avLst/>
@@ -5541,37 +4872,7 @@
             </a:endParaRPr>
           </a:p>
           <a:p>
-            <a:pPr marL="342900" indent="-342900" algn="just">
-              <a:buFont typeface="Arial"/>
-              <a:buChar char="•"/>
-            </a:pPr>
-            <a:endParaRPr lang="en-US" sz="2000" dirty="0">
-              <a:latin typeface="Times New Roman"/>
-              <a:cs typeface="Times New Roman"/>
-            </a:endParaRPr>
-          </a:p>
-          <a:p>
-            <a:pPr marL="342900" indent="-342900" algn="just">
-              <a:buFont typeface="Arial"/>
-              <a:buChar char="•"/>
-            </a:pPr>
-            <a:r>
-              <a:rPr lang="en-US" sz="2000">
-                <a:latin typeface="Times New Roman"/>
-                <a:cs typeface="Times New Roman"/>
-              </a:rPr>
-              <a:t>Keep this slide to these points. Don't paste a long paragraph from the report.</a:t>
-            </a:r>
-            <a:endParaRPr lang="en-US" sz="2000" dirty="0">
-              <a:latin typeface="Times New Roman"/>
-              <a:cs typeface="Times New Roman"/>
-            </a:endParaRPr>
-          </a:p>
-          <a:p>
-            <a:pPr marL="342900" indent="-342900" algn="just">
-              <a:buFont typeface="Arial"/>
-              <a:buChar char="•"/>
-            </a:pPr>
+            <a:pPr algn="just"/>
             <a:endParaRPr lang="en-US" sz="2000" dirty="0">
               <a:latin typeface="Times New Roman"/>
               <a:cs typeface="Times New Roman"/>

</xml_diff>